<commit_message>
updated project presentation slides
</commit_message>
<xml_diff>
--- a/Mid project Update.pptx
+++ b/Mid project Update.pptx
@@ -12,11 +12,12 @@
     <p:sldId id="259" r:id="rId6"/>
     <p:sldId id="264" r:id="rId7"/>
     <p:sldId id="263" r:id="rId8"/>
-    <p:sldId id="267" r:id="rId9"/>
-    <p:sldId id="262" r:id="rId10"/>
-    <p:sldId id="261" r:id="rId11"/>
-    <p:sldId id="260" r:id="rId12"/>
-    <p:sldId id="265" r:id="rId13"/>
+    <p:sldId id="268" r:id="rId9"/>
+    <p:sldId id="267" r:id="rId10"/>
+    <p:sldId id="262" r:id="rId11"/>
+    <p:sldId id="261" r:id="rId12"/>
+    <p:sldId id="260" r:id="rId13"/>
+    <p:sldId id="265" r:id="rId14"/>
   </p:sldIdLst>
   <p:sldSz cx="12192000" cy="6858000"/>
   <p:notesSz cx="6858000" cy="9144000"/>
@@ -6214,7 +6215,7 @@
           <p:cNvPr id="2" name="Title 1">
             <a:extLst>
               <a:ext uri="{FF2B5EF4-FFF2-40B4-BE49-F238E27FC236}">
-                <a16:creationId xmlns:a16="http://schemas.microsoft.com/office/drawing/2014/main" id="{4AC5CB6E-FD33-4419-FD29-5EB30403054C}"/>
+                <a16:creationId xmlns:a16="http://schemas.microsoft.com/office/drawing/2014/main" id="{9582EF6F-E112-DB22-11E9-44E4396BFCF0}"/>
               </a:ext>
             </a:extLst>
           </p:cNvPr>
@@ -6227,16 +6228,14 @@
         </p:nvSpPr>
         <p:spPr/>
         <p:txBody>
-          <a:bodyPr>
-            <a:normAutofit/>
-          </a:bodyPr>
+          <a:bodyPr/>
           <a:lstStyle/>
           <a:p>
             <a:r>
               <a:rPr lang="en-NZ" dirty="0">
                 <a:latin typeface="Century Gothic" panose="020B0502020202020204" pitchFamily="34" charset="0"/>
               </a:rPr>
-              <a:t>Any changes to timeframes that need to be discussed?</a:t>
+              <a:t>What is still to be done?</a:t>
             </a:r>
           </a:p>
         </p:txBody>
@@ -6246,7 +6245,7 @@
           <p:cNvPr id="3" name="Content Placeholder 2">
             <a:extLst>
               <a:ext uri="{FF2B5EF4-FFF2-40B4-BE49-F238E27FC236}">
-                <a16:creationId xmlns:a16="http://schemas.microsoft.com/office/drawing/2014/main" id="{F342F351-5F23-6D92-03AC-5C25C11D2796}"/>
+                <a16:creationId xmlns:a16="http://schemas.microsoft.com/office/drawing/2014/main" id="{E08B6175-1B96-0215-5195-3A92E08F8001}"/>
               </a:ext>
             </a:extLst>
           </p:cNvPr>
@@ -6266,15 +6265,20 @@
               <a:rPr lang="en-NZ" dirty="0">
                 <a:latin typeface="Century Gothic" panose="020B0502020202020204" pitchFamily="34" charset="0"/>
               </a:rPr>
-              <a:t>The time frame has been shifted due to Capstone proposal taking longer than expected. </a:t>
-            </a:r>
+              <a:t>Complete proof of concepts for Wireshark and Nmap</a:t>
+            </a:r>
+          </a:p>
+          <a:p>
+            <a:endParaRPr lang="en-NZ" dirty="0">
+              <a:latin typeface="Century Gothic" panose="020B0502020202020204" pitchFamily="34" charset="0"/>
+            </a:endParaRPr>
           </a:p>
         </p:txBody>
       </p:sp>
     </p:spTree>
     <p:extLst>
       <p:ext uri="{BB962C8B-B14F-4D97-AF65-F5344CB8AC3E}">
-        <p14:creationId xmlns:p14="http://schemas.microsoft.com/office/powerpoint/2010/main" val="68356929"/>
+        <p14:creationId xmlns:p14="http://schemas.microsoft.com/office/powerpoint/2010/main" val="2360615822"/>
       </p:ext>
     </p:extLst>
   </p:cSld>
@@ -6306,6 +6310,98 @@
           <p:cNvPr id="2" name="Title 1">
             <a:extLst>
               <a:ext uri="{FF2B5EF4-FFF2-40B4-BE49-F238E27FC236}">
+                <a16:creationId xmlns:a16="http://schemas.microsoft.com/office/drawing/2014/main" id="{4AC5CB6E-FD33-4419-FD29-5EB30403054C}"/>
+              </a:ext>
+            </a:extLst>
+          </p:cNvPr>
+          <p:cNvSpPr>
+            <a:spLocks noGrp="1"/>
+          </p:cNvSpPr>
+          <p:nvPr>
+            <p:ph type="title"/>
+          </p:nvPr>
+        </p:nvSpPr>
+        <p:spPr/>
+        <p:txBody>
+          <a:bodyPr>
+            <a:normAutofit/>
+          </a:bodyPr>
+          <a:lstStyle/>
+          <a:p>
+            <a:r>
+              <a:rPr lang="en-NZ" dirty="0">
+                <a:latin typeface="Century Gothic" panose="020B0502020202020204" pitchFamily="34" charset="0"/>
+              </a:rPr>
+              <a:t>Any changes to timeframes that need to be discussed?</a:t>
+            </a:r>
+          </a:p>
+        </p:txBody>
+      </p:sp>
+      <p:sp>
+        <p:nvSpPr>
+          <p:cNvPr id="3" name="Content Placeholder 2">
+            <a:extLst>
+              <a:ext uri="{FF2B5EF4-FFF2-40B4-BE49-F238E27FC236}">
+                <a16:creationId xmlns:a16="http://schemas.microsoft.com/office/drawing/2014/main" id="{F342F351-5F23-6D92-03AC-5C25C11D2796}"/>
+              </a:ext>
+            </a:extLst>
+          </p:cNvPr>
+          <p:cNvSpPr>
+            <a:spLocks noGrp="1"/>
+          </p:cNvSpPr>
+          <p:nvPr>
+            <p:ph idx="1"/>
+          </p:nvPr>
+        </p:nvSpPr>
+        <p:spPr/>
+        <p:txBody>
+          <a:bodyPr/>
+          <a:lstStyle/>
+          <a:p>
+            <a:r>
+              <a:rPr lang="en-NZ" dirty="0">
+                <a:latin typeface="Century Gothic" panose="020B0502020202020204" pitchFamily="34" charset="0"/>
+              </a:rPr>
+              <a:t>The time frame has been shifted due to Capstone proposal taking longer than expected. </a:t>
+            </a:r>
+          </a:p>
+        </p:txBody>
+      </p:sp>
+    </p:spTree>
+    <p:extLst>
+      <p:ext uri="{BB962C8B-B14F-4D97-AF65-F5344CB8AC3E}">
+        <p14:creationId xmlns:p14="http://schemas.microsoft.com/office/powerpoint/2010/main" val="68356929"/>
+      </p:ext>
+    </p:extLst>
+  </p:cSld>
+  <p:clrMapOvr>
+    <a:masterClrMapping/>
+  </p:clrMapOvr>
+</p:sld>
+</file>
+
+<file path=ppt/slides/slide12.xml><?xml version="1.0" encoding="utf-8"?>
+<p:sld xmlns:a="http://schemas.openxmlformats.org/drawingml/2006/main" xmlns:r="http://schemas.openxmlformats.org/officeDocument/2006/relationships" xmlns:p="http://schemas.openxmlformats.org/presentationml/2006/main">
+  <p:cSld>
+    <p:spTree>
+      <p:nvGrpSpPr>
+        <p:cNvPr id="1" name=""/>
+        <p:cNvGrpSpPr/>
+        <p:nvPr/>
+      </p:nvGrpSpPr>
+      <p:grpSpPr>
+        <a:xfrm>
+          <a:off x="0" y="0"/>
+          <a:ext cx="0" cy="0"/>
+          <a:chOff x="0" y="0"/>
+          <a:chExt cx="0" cy="0"/>
+        </a:xfrm>
+      </p:grpSpPr>
+      <p:sp>
+        <p:nvSpPr>
+          <p:cNvPr id="2" name="Title 1">
+            <a:extLst>
+              <a:ext uri="{FF2B5EF4-FFF2-40B4-BE49-F238E27FC236}">
                 <a16:creationId xmlns:a16="http://schemas.microsoft.com/office/drawing/2014/main" id="{EF4F9A50-08D3-B5BA-98EE-2A5CB574A435}"/>
               </a:ext>
             </a:extLst>
@@ -6317,7 +6413,12 @@
             <p:ph type="title"/>
           </p:nvPr>
         </p:nvSpPr>
-        <p:spPr/>
+        <p:spPr>
+          <a:xfrm>
+            <a:off x="1177584" y="2728735"/>
+            <a:ext cx="9836832" cy="1400530"/>
+          </a:xfrm>
+        </p:spPr>
         <p:txBody>
           <a:bodyPr/>
           <a:lstStyle/>
@@ -6326,7 +6427,7 @@
               <a:rPr lang="en-NZ" dirty="0">
                 <a:latin typeface="Century Gothic" panose="020B0502020202020204" pitchFamily="34" charset="0"/>
               </a:rPr>
-              <a:t>Overall client feedback/satisfaction</a:t>
+              <a:t>Overall client feedback/satisfaction </a:t>
             </a:r>
           </a:p>
         </p:txBody>
@@ -6344,7 +6445,7 @@
 </p:sld>
 </file>
 
-<file path=ppt/slides/slide12.xml><?xml version="1.0" encoding="utf-8"?>
+<file path=ppt/slides/slide13.xml><?xml version="1.0" encoding="utf-8"?>
 <p:sld xmlns:a="http://schemas.openxmlformats.org/drawingml/2006/main" xmlns:r="http://schemas.openxmlformats.org/officeDocument/2006/relationships" xmlns:p="http://schemas.openxmlformats.org/presentationml/2006/main">
   <p:cSld>
     <p:spTree>
@@ -6451,13 +6552,8 @@
           <a:p>
             <a:r>
               <a:rPr lang="en-NZ" dirty="0"/>
-              <a:t>Learning </a:t>
-            </a:r>
-            <a:r>
-              <a:rPr lang="en-NZ"/>
-              <a:t>Outcomes (LOs)</a:t>
-            </a:r>
-            <a:endParaRPr lang="en-NZ" dirty="0"/>
+              <a:t>Learning Outcomes (LOs)</a:t>
+            </a:r>
           </a:p>
         </p:txBody>
       </p:sp>
@@ -7050,7 +7146,9 @@
         </p:nvSpPr>
         <p:spPr/>
         <p:txBody>
-          <a:bodyPr/>
+          <a:bodyPr>
+            <a:normAutofit lnSpcReduction="10000"/>
+          </a:bodyPr>
           <a:lstStyle/>
           <a:p>
             <a:r>
@@ -7088,12 +7186,6 @@
             </a:r>
           </a:p>
           <a:p>
-            <a:pPr lvl="1"/>
-            <a:endParaRPr lang="en-NZ" dirty="0">
-              <a:latin typeface="Century Gothic" panose="020B0502020202020204" pitchFamily="34" charset="0"/>
-            </a:endParaRPr>
-          </a:p>
-          <a:p>
             <a:pPr marL="0" indent="0">
               <a:buNone/>
             </a:pPr>
@@ -7106,7 +7198,28 @@
               <a:rPr lang="en-NZ" dirty="0">
                 <a:latin typeface="Century Gothic" panose="020B0502020202020204" pitchFamily="34" charset="0"/>
               </a:rPr>
-              <a:t>Meow</a:t>
+              <a:t>Changed from LM studio to Ollama </a:t>
+            </a:r>
+          </a:p>
+          <a:p>
+            <a:endParaRPr lang="en-NZ" dirty="0">
+              <a:latin typeface="Century Gothic" panose="020B0502020202020204" pitchFamily="34" charset="0"/>
+            </a:endParaRPr>
+          </a:p>
+          <a:p>
+            <a:r>
+              <a:rPr lang="en-NZ" dirty="0">
+                <a:latin typeface="Century Gothic" panose="020B0502020202020204" pitchFamily="34" charset="0"/>
+              </a:rPr>
+              <a:t>Project philosophy change. (were going and finding AI tools and comparing them to non ai versions, now we are looking at tools and AI reports vs human reports.)</a:t>
+            </a:r>
+          </a:p>
+          <a:p>
+            <a:r>
+              <a:rPr lang="en-NZ" dirty="0">
+                <a:latin typeface="Century Gothic" panose="020B0502020202020204" pitchFamily="34" charset="0"/>
+              </a:rPr>
+              <a:t>(changed what Geoff expects of us)</a:t>
             </a:r>
           </a:p>
           <a:p>
@@ -7158,7 +7271,7 @@
           <p:cNvPr id="2" name="Title 1">
             <a:extLst>
               <a:ext uri="{FF2B5EF4-FFF2-40B4-BE49-F238E27FC236}">
-                <a16:creationId xmlns:a16="http://schemas.microsoft.com/office/drawing/2014/main" id="{45E0D38A-9B0C-F7EC-7E40-960AD3FE713C}"/>
+                <a16:creationId xmlns:a16="http://schemas.microsoft.com/office/drawing/2014/main" id="{1752F503-BA1E-2D45-51A6-84F7A82F23EE}"/>
               </a:ext>
             </a:extLst>
           </p:cNvPr>
@@ -7176,7 +7289,7 @@
           <a:p>
             <a:r>
               <a:rPr lang="en-NZ" dirty="0"/>
-              <a:t>Foremost Proof of Concept</a:t>
+              <a:t>Emerging insights (matt)</a:t>
             </a:r>
           </a:p>
         </p:txBody>
@@ -7186,7 +7299,7 @@
           <p:cNvPr id="3" name="Content Placeholder 2">
             <a:extLst>
               <a:ext uri="{FF2B5EF4-FFF2-40B4-BE49-F238E27FC236}">
-                <a16:creationId xmlns:a16="http://schemas.microsoft.com/office/drawing/2014/main" id="{A1BF2D46-F7DC-B8C3-2E45-C4E0D2A1E1C9}"/>
+                <a16:creationId xmlns:a16="http://schemas.microsoft.com/office/drawing/2014/main" id="{F2F109EC-CF5E-94D0-6F6D-FCD1015433D6}"/>
               </a:ext>
             </a:extLst>
           </p:cNvPr>
@@ -7202,17 +7315,14 @@
           <a:bodyPr/>
           <a:lstStyle/>
           <a:p>
-            <a:r>
-              <a:rPr lang="en-NZ" dirty="0"/>
-              <a:t>Now we will demonstrate a proof of concept </a:t>
-            </a:r>
+            <a:endParaRPr lang="en-NZ"/>
           </a:p>
         </p:txBody>
       </p:sp>
     </p:spTree>
     <p:extLst>
       <p:ext uri="{BB962C8B-B14F-4D97-AF65-F5344CB8AC3E}">
-        <p14:creationId xmlns:p14="http://schemas.microsoft.com/office/powerpoint/2010/main" val="1251441915"/>
+        <p14:creationId xmlns:p14="http://schemas.microsoft.com/office/powerpoint/2010/main" val="3959275895"/>
       </p:ext>
     </p:extLst>
   </p:cSld>
@@ -7244,7 +7354,7 @@
           <p:cNvPr id="2" name="Title 1">
             <a:extLst>
               <a:ext uri="{FF2B5EF4-FFF2-40B4-BE49-F238E27FC236}">
-                <a16:creationId xmlns:a16="http://schemas.microsoft.com/office/drawing/2014/main" id="{9582EF6F-E112-DB22-11E9-44E4396BFCF0}"/>
+                <a16:creationId xmlns:a16="http://schemas.microsoft.com/office/drawing/2014/main" id="{45E0D38A-9B0C-F7EC-7E40-960AD3FE713C}"/>
               </a:ext>
             </a:extLst>
           </p:cNvPr>
@@ -7261,10 +7371,8 @@
           <a:lstStyle/>
           <a:p>
             <a:r>
-              <a:rPr lang="en-NZ" dirty="0">
-                <a:latin typeface="Century Gothic" panose="020B0502020202020204" pitchFamily="34" charset="0"/>
-              </a:rPr>
-              <a:t>What is still to be done?</a:t>
+              <a:rPr lang="en-NZ" dirty="0"/>
+              <a:t>Foremost Proof of Concept</a:t>
             </a:r>
           </a:p>
         </p:txBody>
@@ -7274,7 +7382,7 @@
           <p:cNvPr id="3" name="Content Placeholder 2">
             <a:extLst>
               <a:ext uri="{FF2B5EF4-FFF2-40B4-BE49-F238E27FC236}">
-                <a16:creationId xmlns:a16="http://schemas.microsoft.com/office/drawing/2014/main" id="{E08B6175-1B96-0215-5195-3A92E08F8001}"/>
+                <a16:creationId xmlns:a16="http://schemas.microsoft.com/office/drawing/2014/main" id="{A1BF2D46-F7DC-B8C3-2E45-C4E0D2A1E1C9}"/>
               </a:ext>
             </a:extLst>
           </p:cNvPr>
@@ -7291,23 +7399,16 @@
           <a:lstStyle/>
           <a:p>
             <a:r>
-              <a:rPr lang="en-NZ" dirty="0">
-                <a:latin typeface="Century Gothic" panose="020B0502020202020204" pitchFamily="34" charset="0"/>
-              </a:rPr>
-              <a:t>Complete proof of concepts for Wireshark and Nmap</a:t>
-            </a:r>
-          </a:p>
-          <a:p>
-            <a:endParaRPr lang="en-NZ" dirty="0">
-              <a:latin typeface="Century Gothic" panose="020B0502020202020204" pitchFamily="34" charset="0"/>
-            </a:endParaRPr>
+              <a:rPr lang="en-NZ" dirty="0"/>
+              <a:t>Now we will demonstrate a proof of concept </a:t>
+            </a:r>
           </a:p>
         </p:txBody>
       </p:sp>
     </p:spTree>
     <p:extLst>
       <p:ext uri="{BB962C8B-B14F-4D97-AF65-F5344CB8AC3E}">
-        <p14:creationId xmlns:p14="http://schemas.microsoft.com/office/powerpoint/2010/main" val="2360615822"/>
+        <p14:creationId xmlns:p14="http://schemas.microsoft.com/office/powerpoint/2010/main" val="1251441915"/>
       </p:ext>
     </p:extLst>
   </p:cSld>

</xml_diff>

<commit_message>
added effort to my emerging insights and foremost script sections of tthe mid project presentation, updated weekly log
</commit_message>
<xml_diff>
--- a/Mid project Update.pptx
+++ b/Mid project Update.pptx
@@ -12,8 +12,8 @@
     <p:sldId id="259" r:id="rId6"/>
     <p:sldId id="264" r:id="rId7"/>
     <p:sldId id="263" r:id="rId8"/>
-    <p:sldId id="268" r:id="rId9"/>
-    <p:sldId id="267" r:id="rId10"/>
+    <p:sldId id="267" r:id="rId9"/>
+    <p:sldId id="268" r:id="rId10"/>
     <p:sldId id="262" r:id="rId11"/>
     <p:sldId id="261" r:id="rId12"/>
     <p:sldId id="260" r:id="rId13"/>
@@ -116,6 +116,11 @@
       </a:defRPr>
     </a:lvl9pPr>
   </p:defaultTextStyle>
+  <p:extLst>
+    <p:ext uri="{EFAFB233-063F-42B5-8137-9DF3F51BA10A}">
+      <p15:sldGuideLst xmlns:p15="http://schemas.microsoft.com/office/powerpoint/2012/main"/>
+    </p:ext>
+  </p:extLst>
 </p:presentation>
 </file>
 
@@ -305,7 +310,7 @@
           <a:p>
             <a:fld id="{82AFC869-5EEF-42A8-8244-0DD91ADCD842}" type="datetimeFigureOut">
               <a:rPr lang="en-NZ" smtClean="0"/>
-              <a:t>8/09/2026</a:t>
+              <a:t>11/09/2026</a:t>
             </a:fld>
             <a:endParaRPr lang="en-NZ"/>
           </a:p>
@@ -580,7 +585,7 @@
           <a:p>
             <a:fld id="{82AFC869-5EEF-42A8-8244-0DD91ADCD842}" type="datetimeFigureOut">
               <a:rPr lang="en-NZ" smtClean="0"/>
-              <a:t>8/09/2026</a:t>
+              <a:t>11/09/2026</a:t>
             </a:fld>
             <a:endParaRPr lang="en-NZ"/>
           </a:p>
@@ -774,7 +779,7 @@
           <a:p>
             <a:fld id="{82AFC869-5EEF-42A8-8244-0DD91ADCD842}" type="datetimeFigureOut">
               <a:rPr lang="en-NZ" smtClean="0"/>
-              <a:t>8/09/2026</a:t>
+              <a:t>11/09/2026</a:t>
             </a:fld>
             <a:endParaRPr lang="en-NZ"/>
           </a:p>
@@ -1047,7 +1052,7 @@
           <a:p>
             <a:fld id="{82AFC869-5EEF-42A8-8244-0DD91ADCD842}" type="datetimeFigureOut">
               <a:rPr lang="en-NZ" smtClean="0"/>
-              <a:t>8/09/2026</a:t>
+              <a:t>11/09/2026</a:t>
             </a:fld>
             <a:endParaRPr lang="en-NZ"/>
           </a:p>
@@ -1388,7 +1393,7 @@
           <a:p>
             <a:fld id="{82AFC869-5EEF-42A8-8244-0DD91ADCD842}" type="datetimeFigureOut">
               <a:rPr lang="en-NZ" smtClean="0"/>
-              <a:t>8/09/2026</a:t>
+              <a:t>11/09/2026</a:t>
             </a:fld>
             <a:endParaRPr lang="en-NZ"/>
           </a:p>
@@ -2011,7 +2016,7 @@
           <a:p>
             <a:fld id="{82AFC869-5EEF-42A8-8244-0DD91ADCD842}" type="datetimeFigureOut">
               <a:rPr lang="en-NZ" smtClean="0"/>
-              <a:t>8/09/2026</a:t>
+              <a:t>11/09/2026</a:t>
             </a:fld>
             <a:endParaRPr lang="en-NZ"/>
           </a:p>
@@ -2871,7 +2876,7 @@
           <a:p>
             <a:fld id="{82AFC869-5EEF-42A8-8244-0DD91ADCD842}" type="datetimeFigureOut">
               <a:rPr lang="en-NZ" smtClean="0"/>
-              <a:t>8/09/2026</a:t>
+              <a:t>11/09/2026</a:t>
             </a:fld>
             <a:endParaRPr lang="en-NZ"/>
           </a:p>
@@ -3041,7 +3046,7 @@
           <a:p>
             <a:fld id="{82AFC869-5EEF-42A8-8244-0DD91ADCD842}" type="datetimeFigureOut">
               <a:rPr lang="en-NZ" smtClean="0"/>
-              <a:t>8/09/2026</a:t>
+              <a:t>11/09/2026</a:t>
             </a:fld>
             <a:endParaRPr lang="en-NZ"/>
           </a:p>
@@ -3221,7 +3226,7 @@
           <a:p>
             <a:fld id="{82AFC869-5EEF-42A8-8244-0DD91ADCD842}" type="datetimeFigureOut">
               <a:rPr lang="en-NZ" smtClean="0"/>
-              <a:t>8/09/2026</a:t>
+              <a:t>11/09/2026</a:t>
             </a:fld>
             <a:endParaRPr lang="en-NZ"/>
           </a:p>
@@ -3391,7 +3396,7 @@
           <a:p>
             <a:fld id="{82AFC869-5EEF-42A8-8244-0DD91ADCD842}" type="datetimeFigureOut">
               <a:rPr lang="en-NZ" smtClean="0"/>
-              <a:t>8/09/2026</a:t>
+              <a:t>11/09/2026</a:t>
             </a:fld>
             <a:endParaRPr lang="en-NZ"/>
           </a:p>
@@ -3638,7 +3643,7 @@
           <a:p>
             <a:fld id="{82AFC869-5EEF-42A8-8244-0DD91ADCD842}" type="datetimeFigureOut">
               <a:rPr lang="en-NZ" smtClean="0"/>
-              <a:t>8/09/2026</a:t>
+              <a:t>11/09/2026</a:t>
             </a:fld>
             <a:endParaRPr lang="en-NZ"/>
           </a:p>
@@ -3930,7 +3935,7 @@
           <a:p>
             <a:fld id="{82AFC869-5EEF-42A8-8244-0DD91ADCD842}" type="datetimeFigureOut">
               <a:rPr lang="en-NZ" smtClean="0"/>
-              <a:t>8/09/2026</a:t>
+              <a:t>11/09/2026</a:t>
             </a:fld>
             <a:endParaRPr lang="en-NZ"/>
           </a:p>
@@ -4374,7 +4379,7 @@
           <a:p>
             <a:fld id="{82AFC869-5EEF-42A8-8244-0DD91ADCD842}" type="datetimeFigureOut">
               <a:rPr lang="en-NZ" smtClean="0"/>
-              <a:t>8/09/2026</a:t>
+              <a:t>11/09/2026</a:t>
             </a:fld>
             <a:endParaRPr lang="en-NZ"/>
           </a:p>
@@ -4492,7 +4497,7 @@
           <a:p>
             <a:fld id="{82AFC869-5EEF-42A8-8244-0DD91ADCD842}" type="datetimeFigureOut">
               <a:rPr lang="en-NZ" smtClean="0"/>
-              <a:t>8/09/2026</a:t>
+              <a:t>11/09/2026</a:t>
             </a:fld>
             <a:endParaRPr lang="en-NZ"/>
           </a:p>
@@ -4587,7 +4592,7 @@
           <a:p>
             <a:fld id="{82AFC869-5EEF-42A8-8244-0DD91ADCD842}" type="datetimeFigureOut">
               <a:rPr lang="en-NZ" smtClean="0"/>
-              <a:t>8/09/2026</a:t>
+              <a:t>11/09/2026</a:t>
             </a:fld>
             <a:endParaRPr lang="en-NZ"/>
           </a:p>
@@ -4866,7 +4871,7 @@
           <a:p>
             <a:fld id="{82AFC869-5EEF-42A8-8244-0DD91ADCD842}" type="datetimeFigureOut">
               <a:rPr lang="en-NZ" smtClean="0"/>
-              <a:t>8/09/2026</a:t>
+              <a:t>11/09/2026</a:t>
             </a:fld>
             <a:endParaRPr lang="en-NZ"/>
           </a:p>
@@ -5141,7 +5146,7 @@
           <a:p>
             <a:fld id="{82AFC869-5EEF-42A8-8244-0DD91ADCD842}" type="datetimeFigureOut">
               <a:rPr lang="en-NZ" smtClean="0"/>
-              <a:t>8/09/2026</a:t>
+              <a:t>11/09/2026</a:t>
             </a:fld>
             <a:endParaRPr lang="en-NZ"/>
           </a:p>
@@ -5584,7 +5589,7 @@
           <a:p>
             <a:fld id="{82AFC869-5EEF-42A8-8244-0DD91ADCD842}" type="datetimeFigureOut">
               <a:rPr lang="en-NZ" smtClean="0"/>
-              <a:t>8/09/2026</a:t>
+              <a:t>11/09/2026</a:t>
             </a:fld>
             <a:endParaRPr lang="en-NZ"/>
           </a:p>
@@ -7271,7 +7276,7 @@
           <p:cNvPr id="2" name="Title 1">
             <a:extLst>
               <a:ext uri="{FF2B5EF4-FFF2-40B4-BE49-F238E27FC236}">
-                <a16:creationId xmlns:a16="http://schemas.microsoft.com/office/drawing/2014/main" id="{1752F503-BA1E-2D45-51A6-84F7A82F23EE}"/>
+                <a16:creationId xmlns:a16="http://schemas.microsoft.com/office/drawing/2014/main" id="{45E0D38A-9B0C-F7EC-7E40-960AD3FE713C}"/>
               </a:ext>
             </a:extLst>
           </p:cNvPr>
@@ -7289,7 +7294,7 @@
           <a:p>
             <a:r>
               <a:rPr lang="en-NZ" dirty="0"/>
-              <a:t>Emerging insights (matt)</a:t>
+              <a:t>Foremost Proof of Concept</a:t>
             </a:r>
           </a:p>
         </p:txBody>
@@ -7299,7 +7304,7 @@
           <p:cNvPr id="3" name="Content Placeholder 2">
             <a:extLst>
               <a:ext uri="{FF2B5EF4-FFF2-40B4-BE49-F238E27FC236}">
-                <a16:creationId xmlns:a16="http://schemas.microsoft.com/office/drawing/2014/main" id="{F2F109EC-CF5E-94D0-6F6D-FCD1015433D6}"/>
+                <a16:creationId xmlns:a16="http://schemas.microsoft.com/office/drawing/2014/main" id="{A1BF2D46-F7DC-B8C3-2E45-C4E0D2A1E1C9}"/>
               </a:ext>
             </a:extLst>
           </p:cNvPr>
@@ -7310,19 +7315,56 @@
             <p:ph idx="1"/>
           </p:nvPr>
         </p:nvSpPr>
-        <p:spPr/>
-        <p:txBody>
-          <a:bodyPr/>
-          <a:lstStyle/>
-          <a:p>
-            <a:endParaRPr lang="en-NZ"/>
+        <p:spPr>
+          <a:xfrm>
+            <a:off x="1104293" y="1577430"/>
+            <a:ext cx="8946541" cy="4195481"/>
+          </a:xfrm>
+        </p:spPr>
+        <p:txBody>
+          <a:bodyPr>
+            <a:normAutofit lnSpcReduction="10000"/>
+          </a:bodyPr>
+          <a:lstStyle/>
+          <a:p>
+            <a:r>
+              <a:rPr lang="en-US" dirty="0"/>
+              <a:t>Foremost “carves” files from forensic disk images. Disk images are bit-by-bit copies of a storage medium. File carving is an essential practice in digital forensics.</a:t>
+            </a:r>
+          </a:p>
+          <a:p>
+            <a:r>
+              <a:rPr lang="en-US" dirty="0"/>
+              <a:t>The team developed a Python 3 script that is used to automate the examination of the “audit.txt” file from Foremost to produce a report.</a:t>
+            </a:r>
+          </a:p>
+          <a:p>
+            <a:r>
+              <a:rPr lang="en-US" dirty="0"/>
+              <a:t>The team also experimented with a script that directly inspects the carved files. Despite promising results, this has been commented out of the script because it has not been optimized yet.</a:t>
+            </a:r>
+          </a:p>
+          <a:p>
+            <a:r>
+              <a:rPr lang="en-US" dirty="0"/>
+              <a:t>The script also serves to record how long the process takes.</a:t>
+            </a:r>
+          </a:p>
+          <a:p>
+            <a:r>
+              <a:rPr lang="en-US" dirty="0"/>
+              <a:t>This effort represents the successful development/integration of AI enhancement to a digital forensics tool.</a:t>
+            </a:r>
+          </a:p>
+          <a:p>
+            <a:endParaRPr lang="en-US" dirty="0"/>
           </a:p>
         </p:txBody>
       </p:sp>
     </p:spTree>
     <p:extLst>
       <p:ext uri="{BB962C8B-B14F-4D97-AF65-F5344CB8AC3E}">
-        <p14:creationId xmlns:p14="http://schemas.microsoft.com/office/powerpoint/2010/main" val="3959275895"/>
+        <p14:creationId xmlns:p14="http://schemas.microsoft.com/office/powerpoint/2010/main" val="1251441915"/>
       </p:ext>
     </p:extLst>
   </p:cSld>
@@ -7354,7 +7396,7 @@
           <p:cNvPr id="2" name="Title 1">
             <a:extLst>
               <a:ext uri="{FF2B5EF4-FFF2-40B4-BE49-F238E27FC236}">
-                <a16:creationId xmlns:a16="http://schemas.microsoft.com/office/drawing/2014/main" id="{45E0D38A-9B0C-F7EC-7E40-960AD3FE713C}"/>
+                <a16:creationId xmlns:a16="http://schemas.microsoft.com/office/drawing/2014/main" id="{1752F503-BA1E-2D45-51A6-84F7A82F23EE}"/>
               </a:ext>
             </a:extLst>
           </p:cNvPr>
@@ -7372,7 +7414,7 @@
           <a:p>
             <a:r>
               <a:rPr lang="en-NZ" dirty="0"/>
-              <a:t>Foremost Proof of Concept</a:t>
+              <a:t>Emerging Insights</a:t>
             </a:r>
           </a:p>
         </p:txBody>
@@ -7382,7 +7424,7 @@
           <p:cNvPr id="3" name="Content Placeholder 2">
             <a:extLst>
               <a:ext uri="{FF2B5EF4-FFF2-40B4-BE49-F238E27FC236}">
-                <a16:creationId xmlns:a16="http://schemas.microsoft.com/office/drawing/2014/main" id="{A1BF2D46-F7DC-B8C3-2E45-C4E0D2A1E1C9}"/>
+                <a16:creationId xmlns:a16="http://schemas.microsoft.com/office/drawing/2014/main" id="{F2F109EC-CF5E-94D0-6F6D-FCD1015433D6}"/>
               </a:ext>
             </a:extLst>
           </p:cNvPr>
@@ -7393,22 +7435,93 @@
             <p:ph idx="1"/>
           </p:nvPr>
         </p:nvSpPr>
-        <p:spPr/>
-        <p:txBody>
-          <a:bodyPr/>
-          <a:lstStyle/>
-          <a:p>
-            <a:r>
-              <a:rPr lang="en-NZ" dirty="0"/>
-              <a:t>Now we will demonstrate a proof of concept </a:t>
-            </a:r>
-          </a:p>
-        </p:txBody>
-      </p:sp>
+        <p:spPr>
+          <a:xfrm>
+            <a:off x="1104293" y="2089013"/>
+            <a:ext cx="8946541" cy="4195481"/>
+          </a:xfrm>
+        </p:spPr>
+        <p:txBody>
+          <a:bodyPr/>
+          <a:lstStyle/>
+          <a:p>
+            <a:r>
+              <a:rPr lang="en-US" dirty="0"/>
+              <a:t>LLM falsifies names of the target disk image, and version of foremost used. This is because if audit.txt is too large, the context restricts the thinking to the lower half of the text file.</a:t>
+            </a:r>
+          </a:p>
+          <a:p>
+            <a:endParaRPr lang="en-US" dirty="0"/>
+          </a:p>
+          <a:p>
+            <a:endParaRPr lang="en-NZ" dirty="0"/>
+          </a:p>
+        </p:txBody>
+      </p:sp>
+      <p:pic>
+        <p:nvPicPr>
+          <p:cNvPr id="7" name="Picture 6">
+            <a:extLst>
+              <a:ext uri="{FF2B5EF4-FFF2-40B4-BE49-F238E27FC236}">
+                <a16:creationId xmlns:a16="http://schemas.microsoft.com/office/drawing/2014/main" id="{37A62E3D-0BE2-059B-5714-5AEFB44D7ADD}"/>
+              </a:ext>
+            </a:extLst>
+          </p:cNvPr>
+          <p:cNvPicPr>
+            <a:picLocks noChangeAspect="1"/>
+          </p:cNvPicPr>
+          <p:nvPr/>
+        </p:nvPicPr>
+        <p:blipFill>
+          <a:blip r:embed="rId2"/>
+          <a:stretch>
+            <a:fillRect/>
+          </a:stretch>
+        </p:blipFill>
+        <p:spPr>
+          <a:xfrm>
+            <a:off x="1223627" y="4298796"/>
+            <a:ext cx="4583378" cy="1172049"/>
+          </a:xfrm>
+          <a:prstGeom prst="rect">
+            <a:avLst/>
+          </a:prstGeom>
+        </p:spPr>
+      </p:pic>
+      <p:pic>
+        <p:nvPicPr>
+          <p:cNvPr id="11" name="Picture 10">
+            <a:extLst>
+              <a:ext uri="{FF2B5EF4-FFF2-40B4-BE49-F238E27FC236}">
+                <a16:creationId xmlns:a16="http://schemas.microsoft.com/office/drawing/2014/main" id="{C18BD18F-68DF-AC29-2D4D-0AD51F8E4A3B}"/>
+              </a:ext>
+            </a:extLst>
+          </p:cNvPr>
+          <p:cNvPicPr>
+            <a:picLocks noChangeAspect="1"/>
+          </p:cNvPicPr>
+          <p:nvPr/>
+        </p:nvPicPr>
+        <p:blipFill>
+          <a:blip r:embed="rId3"/>
+          <a:stretch>
+            <a:fillRect/>
+          </a:stretch>
+        </p:blipFill>
+        <p:spPr>
+          <a:xfrm>
+            <a:off x="7032153" y="2954288"/>
+            <a:ext cx="4365216" cy="3861064"/>
+          </a:xfrm>
+          <a:prstGeom prst="rect">
+            <a:avLst/>
+          </a:prstGeom>
+        </p:spPr>
+      </p:pic>
     </p:spTree>
     <p:extLst>
       <p:ext uri="{BB962C8B-B14F-4D97-AF65-F5344CB8AC3E}">
-        <p14:creationId xmlns:p14="http://schemas.microsoft.com/office/powerpoint/2010/main" val="1251441915"/>
+        <p14:creationId xmlns:p14="http://schemas.microsoft.com/office/powerpoint/2010/main" val="3959275895"/>
       </p:ext>
     </p:extLst>
   </p:cSld>

</xml_diff>